<commit_message>
feat: cap nhat Website on tap Tin hoc GK1 (Lop 3-8), bo de DGDK1 Tuan 09-10 va LBG Tuan 09
</commit_message>
<xml_diff>
--- a/KHBD_Tin_học/Lớp_6/Tuần_08/Slide_Tin_hoc_Lớp_6_Tiet07_Bai_4_Mang_may_tinh_Tiet_1.pptx
+++ b/KHBD_Tin_học/Lớp_6/Tuần_08/Slide_Tin_hoc_Lớp_6_Tiet07_Bai_4_Mang_may_tinh_Tiet_1.pptx
@@ -5,12 +5,12 @@
     <p:sldMasterId id="2147483648" r:id="rId1"/>
   </p:sldMasterIdLst>
   <p:sldIdLst>
-    <p:sldId id="256" r:id="rId5"/>
-    <p:sldId id="257" r:id="rId4"/>
-    <p:sldId id="258" r:id="rId3"/>
-    <p:sldId id="259" r:id="rId2"/>
-    <p:sldId id="260" r:id="rId10"/>
-    <p:sldId id="261" r:id="rId11"/>
+    <p:sldId id="256" r:id="rId2"/>
+    <p:sldId id="257" r:id="rId3"/>
+    <p:sldId id="258" r:id="rId4"/>
+    <p:sldId id="259" r:id="rId5"/>
+    <p:sldId id="260" r:id="rId6"/>
+    <p:sldId id="261" r:id="rId7"/>
   </p:sldIdLst>
   <p:sldSz cx="12192000" cy="6858000"/>
   <p:notesSz cx="6858000" cy="9144000"/>
@@ -109,6 +109,11 @@
       </a:defRPr>
     </a:lvl9pPr>
   </p:defaultTextStyle>
+  <p:extLst>
+    <p:ext uri="{EFAFB233-063F-42B5-8137-9DF3F51BA10A}">
+      <p15:sldGuideLst xmlns:p15="http://schemas.microsoft.com/office/powerpoint/2012/main"/>
+    </p:ext>
+  </p:extLst>
 </p:presentation>
 </file>
 
@@ -259,7 +264,7 @@
           <a:p>
             <a:fld id="{4EA7EFA5-8E37-463D-AE92-97FC5095B482}" type="datetimeFigureOut">
               <a:rPr lang="en-US" smtClean="0"/>
-              <a:t>8/4/2026</a:t>
+              <a:t>9/25/2026</a:t>
             </a:fld>
             <a:endParaRPr lang="en-US"/>
           </a:p>
@@ -457,7 +462,7 @@
           <a:p>
             <a:fld id="{4EA7EFA5-8E37-463D-AE92-97FC5095B482}" type="datetimeFigureOut">
               <a:rPr lang="en-US" smtClean="0"/>
-              <a:t>8/4/2026</a:t>
+              <a:t>9/25/2026</a:t>
             </a:fld>
             <a:endParaRPr lang="en-US"/>
           </a:p>
@@ -665,7 +670,7 @@
           <a:p>
             <a:fld id="{4EA7EFA5-8E37-463D-AE92-97FC5095B482}" type="datetimeFigureOut">
               <a:rPr lang="en-US" smtClean="0"/>
-              <a:t>8/4/2026</a:t>
+              <a:t>9/25/2026</a:t>
             </a:fld>
             <a:endParaRPr lang="en-US"/>
           </a:p>
@@ -863,7 +868,7 @@
           <a:p>
             <a:fld id="{4EA7EFA5-8E37-463D-AE92-97FC5095B482}" type="datetimeFigureOut">
               <a:rPr lang="en-US" smtClean="0"/>
-              <a:t>8/4/2026</a:t>
+              <a:t>9/25/2026</a:t>
             </a:fld>
             <a:endParaRPr lang="en-US"/>
           </a:p>
@@ -1138,7 +1143,7 @@
           <a:p>
             <a:fld id="{4EA7EFA5-8E37-463D-AE92-97FC5095B482}" type="datetimeFigureOut">
               <a:rPr lang="en-US" smtClean="0"/>
-              <a:t>8/4/2026</a:t>
+              <a:t>9/25/2026</a:t>
             </a:fld>
             <a:endParaRPr lang="en-US"/>
           </a:p>
@@ -1403,7 +1408,7 @@
           <a:p>
             <a:fld id="{4EA7EFA5-8E37-463D-AE92-97FC5095B482}" type="datetimeFigureOut">
               <a:rPr lang="en-US" smtClean="0"/>
-              <a:t>8/4/2026</a:t>
+              <a:t>9/25/2026</a:t>
             </a:fld>
             <a:endParaRPr lang="en-US"/>
           </a:p>
@@ -1815,7 +1820,7 @@
           <a:p>
             <a:fld id="{4EA7EFA5-8E37-463D-AE92-97FC5095B482}" type="datetimeFigureOut">
               <a:rPr lang="en-US" smtClean="0"/>
-              <a:t>8/4/2026</a:t>
+              <a:t>9/25/2026</a:t>
             </a:fld>
             <a:endParaRPr lang="en-US"/>
           </a:p>
@@ -1956,7 +1961,7 @@
           <a:p>
             <a:fld id="{4EA7EFA5-8E37-463D-AE92-97FC5095B482}" type="datetimeFigureOut">
               <a:rPr lang="en-US" smtClean="0"/>
-              <a:t>8/4/2026</a:t>
+              <a:t>9/25/2026</a:t>
             </a:fld>
             <a:endParaRPr lang="en-US"/>
           </a:p>
@@ -2069,7 +2074,7 @@
           <a:p>
             <a:fld id="{4EA7EFA5-8E37-463D-AE92-97FC5095B482}" type="datetimeFigureOut">
               <a:rPr lang="en-US" smtClean="0"/>
-              <a:t>8/4/2026</a:t>
+              <a:t>9/25/2026</a:t>
             </a:fld>
             <a:endParaRPr lang="en-US"/>
           </a:p>
@@ -2380,7 +2385,7 @@
           <a:p>
             <a:fld id="{4EA7EFA5-8E37-463D-AE92-97FC5095B482}" type="datetimeFigureOut">
               <a:rPr lang="en-US" smtClean="0"/>
-              <a:t>8/4/2026</a:t>
+              <a:t>9/25/2026</a:t>
             </a:fld>
             <a:endParaRPr lang="en-US"/>
           </a:p>
@@ -2668,7 +2673,7 @@
           <a:p>
             <a:fld id="{4EA7EFA5-8E37-463D-AE92-97FC5095B482}" type="datetimeFigureOut">
               <a:rPr lang="en-US" smtClean="0"/>
-              <a:t>8/4/2026</a:t>
+              <a:t>9/25/2026</a:t>
             </a:fld>
             <a:endParaRPr lang="en-US"/>
           </a:p>
@@ -2909,7 +2914,7 @@
           <a:p>
             <a:fld id="{4EA7EFA5-8E37-463D-AE92-97FC5095B482}" type="datetimeFigureOut">
               <a:rPr lang="en-US" smtClean="0"/>
-              <a:t>8/4/2026</a:t>
+              <a:t>9/25/2026</a:t>
             </a:fld>
             <a:endParaRPr lang="en-US"/>
           </a:p>
@@ -3383,7 +3388,7 @@
 </file>
 
 <file path=ppt/slides/slide1.xml><?xml version="1.0" encoding="utf-8"?>
-<p:sld xmlns:a="http://schemas.openxmlformats.org/drawingml/2006/main" xmlns:p="http://schemas.openxmlformats.org/presentationml/2006/main" xmlns:r="http://schemas.openxmlformats.org/officeDocument/2006/relationships">
+<p:sld xmlns:a="http://schemas.openxmlformats.org/drawingml/2006/main" xmlns:r="http://schemas.openxmlformats.org/officeDocument/2006/relationships" xmlns:p="http://schemas.openxmlformats.org/presentationml/2006/main">
   <p:cSld>
     <p:spTree>
       <p:nvGrpSpPr>
@@ -3391,7 +3396,14 @@
         <p:cNvGrpSpPr/>
         <p:nvPr/>
       </p:nvGrpSpPr>
-      <p:grpSpPr/>
+      <p:grpSpPr>
+        <a:xfrm>
+          <a:off x="0" y="0"/>
+          <a:ext cx="0" cy="0"/>
+          <a:chOff x="0" y="0"/>
+          <a:chExt cx="0" cy="0"/>
+        </a:xfrm>
+      </p:grpSpPr>
       <p:sp>
         <p:nvSpPr>
           <p:cNvPr id="2" name="Rectangle 1"/>
@@ -3432,6 +3444,7 @@
           <a:lstStyle/>
           <a:p>
             <a:pPr algn="ctr"/>
+            <a:endParaRPr/>
           </a:p>
         </p:txBody>
       </p:sp>
@@ -3473,7 +3486,7 @@
           </a:fontRef>
         </p:style>
         <p:txBody>
-          <a:bodyPr rtlCol="0" anchor="ctr" wrap="none"/>
+          <a:bodyPr wrap="none" rtlCol="0" anchor="ctr"/>
           <a:lstStyle/>
           <a:p>
             <a:pPr algn="ctr">
@@ -3599,7 +3612,7 @@
 </file>
 
 <file path=ppt/slides/slide2.xml><?xml version="1.0" encoding="utf-8"?>
-<p:sld xmlns:a="http://schemas.openxmlformats.org/drawingml/2006/main" xmlns:p="http://schemas.openxmlformats.org/presentationml/2006/main" xmlns:r="http://schemas.openxmlformats.org/officeDocument/2006/relationships">
+<p:sld xmlns:a="http://schemas.openxmlformats.org/drawingml/2006/main" xmlns:r="http://schemas.openxmlformats.org/officeDocument/2006/relationships" xmlns:p="http://schemas.openxmlformats.org/presentationml/2006/main">
   <p:cSld>
     <p:spTree>
       <p:nvGrpSpPr>
@@ -3607,7 +3620,14 @@
         <p:cNvGrpSpPr/>
         <p:nvPr/>
       </p:nvGrpSpPr>
-      <p:grpSpPr/>
+      <p:grpSpPr>
+        <a:xfrm>
+          <a:off x="0" y="0"/>
+          <a:ext cx="0" cy="0"/>
+          <a:chOff x="0" y="0"/>
+          <a:chExt cx="0" cy="0"/>
+        </a:xfrm>
+      </p:grpSpPr>
       <p:sp>
         <p:nvSpPr>
           <p:cNvPr id="2" name="Rounded Rectangle 1"/>
@@ -3646,7 +3666,7 @@
           </a:fontRef>
         </p:style>
         <p:txBody>
-          <a:bodyPr rtlCol="0" anchor="ctr" wrap="none"/>
+          <a:bodyPr wrap="none" rtlCol="0" anchor="ctr"/>
           <a:lstStyle/>
           <a:p>
             <a:pPr algn="ctr">
@@ -3743,6 +3763,7 @@
           <a:lstStyle/>
           <a:p>
             <a:pPr algn="ctr"/>
+            <a:endParaRPr/>
           </a:p>
         </p:txBody>
       </p:sp>
@@ -3830,7 +3851,7 @@
 </file>
 
 <file path=ppt/slides/slide3.xml><?xml version="1.0" encoding="utf-8"?>
-<p:sld xmlns:a="http://schemas.openxmlformats.org/drawingml/2006/main" xmlns:p="http://schemas.openxmlformats.org/presentationml/2006/main" xmlns:r="http://schemas.openxmlformats.org/officeDocument/2006/relationships">
+<p:sld xmlns:a="http://schemas.openxmlformats.org/drawingml/2006/main" xmlns:r="http://schemas.openxmlformats.org/officeDocument/2006/relationships" xmlns:p="http://schemas.openxmlformats.org/presentationml/2006/main">
   <p:cSld>
     <p:spTree>
       <p:nvGrpSpPr>
@@ -3838,7 +3859,14 @@
         <p:cNvGrpSpPr/>
         <p:nvPr/>
       </p:nvGrpSpPr>
-      <p:grpSpPr/>
+      <p:grpSpPr>
+        <a:xfrm>
+          <a:off x="0" y="0"/>
+          <a:ext cx="0" cy="0"/>
+          <a:chOff x="0" y="0"/>
+          <a:chExt cx="0" cy="0"/>
+        </a:xfrm>
+      </p:grpSpPr>
       <p:sp>
         <p:nvSpPr>
           <p:cNvPr id="2" name="Rounded Rectangle 1"/>
@@ -3877,7 +3905,7 @@
           </a:fontRef>
         </p:style>
         <p:txBody>
-          <a:bodyPr rtlCol="0" anchor="ctr" wrap="none"/>
+          <a:bodyPr wrap="none" rtlCol="0" anchor="ctr"/>
           <a:lstStyle/>
           <a:p>
             <a:pPr algn="ctr">
@@ -3946,8 +3974,8 @@
         </p:blipFill>
         <p:spPr>
           <a:xfrm>
-            <a:off x="731520" y="2011680"/>
-            <a:ext cx="10698480" cy="3566160"/>
+            <a:off x="676656" y="1993391"/>
+            <a:ext cx="10753344" cy="3882475"/>
           </a:xfrm>
           <a:prstGeom prst="rect">
             <a:avLst/>
@@ -3963,7 +3991,7 @@
 </file>
 
 <file path=ppt/slides/slide4.xml><?xml version="1.0" encoding="utf-8"?>
-<p:sld xmlns:a="http://schemas.openxmlformats.org/drawingml/2006/main" xmlns:p="http://schemas.openxmlformats.org/presentationml/2006/main" xmlns:r="http://schemas.openxmlformats.org/officeDocument/2006/relationships">
+<p:sld xmlns:a="http://schemas.openxmlformats.org/drawingml/2006/main" xmlns:r="http://schemas.openxmlformats.org/officeDocument/2006/relationships" xmlns:p="http://schemas.openxmlformats.org/presentationml/2006/main">
   <p:cSld>
     <p:spTree>
       <p:nvGrpSpPr>
@@ -3971,7 +3999,14 @@
         <p:cNvGrpSpPr/>
         <p:nvPr/>
       </p:nvGrpSpPr>
-      <p:grpSpPr/>
+      <p:grpSpPr>
+        <a:xfrm>
+          <a:off x="0" y="0"/>
+          <a:ext cx="0" cy="0"/>
+          <a:chOff x="0" y="0"/>
+          <a:chExt cx="0" cy="0"/>
+        </a:xfrm>
+      </p:grpSpPr>
       <p:sp>
         <p:nvSpPr>
           <p:cNvPr id="2" name="Rounded Rectangle 1"/>
@@ -4010,7 +4045,7 @@
           </a:fontRef>
         </p:style>
         <p:txBody>
-          <a:bodyPr rtlCol="0" anchor="ctr" wrap="none"/>
+          <a:bodyPr wrap="none" rtlCol="0" anchor="ctr"/>
           <a:lstStyle/>
           <a:p>
             <a:pPr algn="ctr">
@@ -4107,6 +4142,7 @@
           <a:lstStyle/>
           <a:p>
             <a:pPr algn="ctr"/>
+            <a:endParaRPr/>
           </a:p>
         </p:txBody>
       </p:sp>
@@ -4155,7 +4191,7 @@
         <p:spPr>
           <a:xfrm>
             <a:off x="5852160" y="2176272"/>
-            <a:ext cx="5303520" cy="457200"/>
+            <a:ext cx="5303520" cy="369332"/>
           </a:xfrm>
           <a:prstGeom prst="rect">
             <a:avLst/>
@@ -4177,7 +4213,48 @@
               </a:defRPr>
             </a:pPr>
             <a:r>
-              <a:t>➔ THIẾT BỊ ĐẦU CUỐI 💻 (Nơi gửi/nhận dữ liệu)</a:t>
+              <a:rPr dirty="0"/>
+              <a:t>➔ THIẾT BỊ ĐẦU 💻 (</a:t>
+            </a:r>
+            <a:r>
+              <a:rPr dirty="0" err="1"/>
+              <a:t>Nơi</a:t>
+            </a:r>
+            <a:r>
+              <a:rPr dirty="0"/>
+              <a:t> </a:t>
+            </a:r>
+            <a:r>
+              <a:rPr dirty="0" err="1"/>
+              <a:t>gửi</a:t>
+            </a:r>
+            <a:r>
+              <a:rPr dirty="0"/>
+              <a:t>/</a:t>
+            </a:r>
+            <a:r>
+              <a:rPr dirty="0" err="1"/>
+              <a:t>nhận</a:t>
+            </a:r>
+            <a:r>
+              <a:rPr dirty="0"/>
+              <a:t> </a:t>
+            </a:r>
+            <a:r>
+              <a:rPr dirty="0" err="1"/>
+              <a:t>dữ</a:t>
+            </a:r>
+            <a:r>
+              <a:rPr dirty="0"/>
+              <a:t> </a:t>
+            </a:r>
+            <a:r>
+              <a:rPr dirty="0" err="1"/>
+              <a:t>liệu</a:t>
+            </a:r>
+            <a:r>
+              <a:rPr dirty="0"/>
+              <a:t>)</a:t>
             </a:r>
           </a:p>
         </p:txBody>
@@ -4226,6 +4303,7 @@
           <a:lstStyle/>
           <a:p>
             <a:pPr algn="ctr"/>
+            <a:endParaRPr/>
           </a:p>
         </p:txBody>
       </p:sp>
@@ -4345,6 +4423,7 @@
           <a:lstStyle/>
           <a:p>
             <a:pPr algn="ctr"/>
+            <a:endParaRPr/>
           </a:p>
         </p:txBody>
       </p:sp>
@@ -4393,7 +4472,7 @@
         <p:spPr>
           <a:xfrm>
             <a:off x="5852160" y="3968496"/>
-            <a:ext cx="5303520" cy="457200"/>
+            <a:ext cx="5303520" cy="369332"/>
           </a:xfrm>
           <a:prstGeom prst="rect">
             <a:avLst/>
@@ -4415,7 +4494,40 @@
               </a:defRPr>
             </a:pPr>
             <a:r>
-              <a:t>➔ THIẾT BỊ ĐẦU CUỐI 🖨️ (Thiết bị dùng chung)</a:t>
+              <a:rPr dirty="0"/>
+              <a:t>➔ THIẾT BỊ CUỐI 🖨️ (</a:t>
+            </a:r>
+            <a:r>
+              <a:rPr dirty="0" err="1"/>
+              <a:t>Thiết</a:t>
+            </a:r>
+            <a:r>
+              <a:rPr dirty="0"/>
+              <a:t> </a:t>
+            </a:r>
+            <a:r>
+              <a:rPr dirty="0" err="1"/>
+              <a:t>bị</a:t>
+            </a:r>
+            <a:r>
+              <a:rPr dirty="0"/>
+              <a:t> </a:t>
+            </a:r>
+            <a:r>
+              <a:rPr dirty="0" err="1"/>
+              <a:t>dùng</a:t>
+            </a:r>
+            <a:r>
+              <a:rPr dirty="0"/>
+              <a:t> </a:t>
+            </a:r>
+            <a:r>
+              <a:rPr dirty="0" err="1"/>
+              <a:t>chung</a:t>
+            </a:r>
+            <a:r>
+              <a:rPr dirty="0"/>
+              <a:t>)</a:t>
             </a:r>
           </a:p>
         </p:txBody>
@@ -4464,6 +4576,7 @@
           <a:lstStyle/>
           <a:p>
             <a:pPr algn="ctr"/>
+            <a:endParaRPr/>
           </a:p>
         </p:txBody>
       </p:sp>
@@ -4548,7 +4661,7 @@
 </file>
 
 <file path=ppt/slides/slide5.xml><?xml version="1.0" encoding="utf-8"?>
-<p:sld xmlns:a="http://schemas.openxmlformats.org/drawingml/2006/main" xmlns:p="http://schemas.openxmlformats.org/presentationml/2006/main" xmlns:r="http://schemas.openxmlformats.org/officeDocument/2006/relationships">
+<p:sld xmlns:a="http://schemas.openxmlformats.org/drawingml/2006/main" xmlns:r="http://schemas.openxmlformats.org/officeDocument/2006/relationships" xmlns:p="http://schemas.openxmlformats.org/presentationml/2006/main">
   <p:cSld>
     <p:spTree>
       <p:nvGrpSpPr>
@@ -4556,7 +4669,14 @@
         <p:cNvGrpSpPr/>
         <p:nvPr/>
       </p:nvGrpSpPr>
-      <p:grpSpPr/>
+      <p:grpSpPr>
+        <a:xfrm>
+          <a:off x="0" y="0"/>
+          <a:ext cx="0" cy="0"/>
+          <a:chOff x="0" y="0"/>
+          <a:chExt cx="0" cy="0"/>
+        </a:xfrm>
+      </p:grpSpPr>
       <p:sp>
         <p:nvSpPr>
           <p:cNvPr id="2" name="Rounded Rectangle 1"/>
@@ -4595,7 +4715,7 @@
           </a:fontRef>
         </p:style>
         <p:txBody>
-          <a:bodyPr rtlCol="0" anchor="ctr" wrap="none"/>
+          <a:bodyPr wrap="none" rtlCol="0" anchor="ctr"/>
           <a:lstStyle/>
           <a:p>
             <a:pPr algn="ctr">
@@ -4692,6 +4812,7 @@
           <a:lstStyle/>
           <a:p>
             <a:pPr algn="ctr"/>
+            <a:endParaRPr/>
           </a:p>
         </p:txBody>
       </p:sp>
@@ -4737,6 +4858,7 @@
           <a:lstStyle/>
           <a:p>
             <a:pPr algn="ctr"/>
+            <a:endParaRPr/>
           </a:p>
         </p:txBody>
       </p:sp>
@@ -4872,7 +4994,7 @@
 </file>
 
 <file path=ppt/slides/slide6.xml><?xml version="1.0" encoding="utf-8"?>
-<p:sld xmlns:a="http://schemas.openxmlformats.org/drawingml/2006/main" xmlns:p="http://schemas.openxmlformats.org/presentationml/2006/main" xmlns:r="http://schemas.openxmlformats.org/officeDocument/2006/relationships">
+<p:sld xmlns:a="http://schemas.openxmlformats.org/drawingml/2006/main" xmlns:r="http://schemas.openxmlformats.org/officeDocument/2006/relationships" xmlns:p="http://schemas.openxmlformats.org/presentationml/2006/main">
   <p:cSld>
     <p:spTree>
       <p:nvGrpSpPr>
@@ -4880,7 +5002,14 @@
         <p:cNvGrpSpPr/>
         <p:nvPr/>
       </p:nvGrpSpPr>
-      <p:grpSpPr/>
+      <p:grpSpPr>
+        <a:xfrm>
+          <a:off x="0" y="0"/>
+          <a:ext cx="0" cy="0"/>
+          <a:chOff x="0" y="0"/>
+          <a:chExt cx="0" cy="0"/>
+        </a:xfrm>
+      </p:grpSpPr>
       <p:sp>
         <p:nvSpPr>
           <p:cNvPr id="2" name="Rectangle 1"/>
@@ -4921,6 +5050,7 @@
           <a:lstStyle/>
           <a:p>
             <a:pPr algn="ctr"/>
+            <a:endParaRPr/>
           </a:p>
         </p:txBody>
       </p:sp>

</xml_diff>